<commit_message>
LaTeX sample tables (B1, B2), percentage-point wording on A1-A3
Sample-size slides rebuilt from compiled LaTeX with academic titles and
full notes; regression tables now state explicitly that entries are
percentage points, with an interpretation example in the notes.

Co-Authored-By: Claude Fable 5 <noreply@anthropic.com>
Claude-Session: https://claude.ai/code/session_01DNzQPDcr3zfLTraMHUHqUn
</commit_message>
<xml_diff>
--- a/report/data_cluster/robustness_slides.pptx
+++ b/report/data_cluster/robustness_slides.pptx
@@ -3178,7 +3178,7 @@
                 </a:solidFill>
                 <a:latin typeface="Garamond"/>
               </a:rPr>
-              <a:t>Probit average marginal effects, all survey years: N = 84,146 teacher-year observations, calendar 1997–2024. Health, disability and income controls exist only from the 2019 supplement; adding them (2018–24 window, N = 18,571) leaves every margin shown here essentially unchanged.</a:t>
+              <a:t>Probit average marginal effects in percentage points, all survey years: N = 84,146 teacher-year observations, calendar 1997–2024. Health, disability and income controls exist only from the 2019 supplement; adding them (N = 18,571) leaves every margin unchanged.</a:t>
             </a:r>
           </a:p>
         </p:txBody>
@@ -3413,8 +3413,8 @@
         </p:blipFill>
         <p:spPr>
           <a:xfrm>
-            <a:off x="3602574" y="914400"/>
-            <a:ext cx="4956370" cy="5394960"/>
+            <a:off x="3260597" y="914400"/>
+            <a:ext cx="5640324" cy="5394959"/>
           </a:xfrm>
           <a:prstGeom prst="rect">
             <a:avLst/>
@@ -3553,8 +3553,8 @@
         </p:blipFill>
         <p:spPr>
           <a:xfrm>
-            <a:off x="2906871" y="914400"/>
-            <a:ext cx="6347776" cy="5394959"/>
+            <a:off x="2990689" y="914400"/>
+            <a:ext cx="6180141" cy="5394959"/>
           </a:xfrm>
           <a:prstGeom prst="rect">
             <a:avLst/>
@@ -3693,8 +3693,8 @@
         </p:blipFill>
         <p:spPr>
           <a:xfrm>
-            <a:off x="3100655" y="914400"/>
-            <a:ext cx="5960209" cy="5394959"/>
+            <a:off x="2727723" y="914400"/>
+            <a:ext cx="6706072" cy="5394960"/>
           </a:xfrm>
           <a:prstGeom prst="rect">
             <a:avLst/>

</xml_diff>

<commit_message>
Benchmark line on the all-years probit slide
Co-Authored-By: Claude Fable 5 <noreply@anthropic.com>
Claude-Session: https://claude.ai/code/session_01DNzQPDcr3zfLTraMHUHqUn
</commit_message>
<xml_diff>
--- a/report/data_cluster/robustness_slides.pptx
+++ b/report/data_cluster/robustness_slides.pptx
@@ -3108,7 +3108,7 @@
           <a:noFill/>
         </p:spPr>
         <p:txBody>
-          <a:bodyPr wrap="square" lIns="0" rIns="0" tIns="0" bIns="0">
+          <a:bodyPr wrap="square">
             <a:spAutoFit/>
           </a:bodyPr>
           <a:lstStyle/>
@@ -3141,8 +3141,8 @@
         </p:blipFill>
         <p:spPr>
           <a:xfrm>
-            <a:off x="1741516" y="1005840"/>
-            <a:ext cx="8678487" cy="4937760"/>
+            <a:off x="1781694" y="960119"/>
+            <a:ext cx="8598130" cy="4892039"/>
           </a:xfrm>
           <a:prstGeom prst="rect">
             <a:avLst/>
@@ -3157,8 +3157,8 @@
         </p:nvSpPr>
         <p:spPr>
           <a:xfrm>
-            <a:off x="822960" y="6199632"/>
-            <a:ext cx="9326880" cy="457200"/>
+            <a:off x="822960" y="6108192"/>
+            <a:ext cx="9326880" cy="548640"/>
           </a:xfrm>
           <a:prstGeom prst="rect">
             <a:avLst/>
@@ -3166,7 +3166,7 @@
           <a:noFill/>
         </p:spPr>
         <p:txBody>
-          <a:bodyPr wrap="square" lIns="0" rIns="0" tIns="0" bIns="0">
+          <a:bodyPr wrap="square">
             <a:spAutoFit/>
           </a:bodyPr>
           <a:lstStyle/>
@@ -3178,7 +3178,7 @@
                 </a:solidFill>
                 <a:latin typeface="Garamond"/>
               </a:rPr>
-              <a:t>Probit average marginal effects in percentage points, all survey years: N = 84,146 teacher-year observations, calendar 1997–2024. Health, disability and income controls exist only from the 2019 supplement; adding them (N = 18,571) leaves every margin unchanged.</a:t>
+              <a:t>Probit average marginal effects in percentage points; N = 84,146 teacher-year observations, calendar 1997–2024. Benchmark: the sample's average annual leaving probability is 7.7%, so +4.5 points for a new baby raises the risk by over half its baseline. Health, disability and income controls exist only from the 2019 supplement; adding them (N = 18,571) leaves every margin unchanged.</a:t>
             </a:r>
           </a:p>
         </p:txBody>
@@ -3380,7 +3380,7 @@
           <a:noFill/>
         </p:spPr>
         <p:txBody>
-          <a:bodyPr wrap="square" lIns="0" rIns="0" tIns="0" bIns="0">
+          <a:bodyPr wrap="square">
             <a:spAutoFit/>
           </a:bodyPr>
           <a:lstStyle/>
@@ -3520,7 +3520,7 @@
           <a:noFill/>
         </p:spPr>
         <p:txBody>
-          <a:bodyPr wrap="square" lIns="0" rIns="0" tIns="0" bIns="0">
+          <a:bodyPr wrap="square">
             <a:spAutoFit/>
           </a:bodyPr>
           <a:lstStyle/>
@@ -3660,7 +3660,7 @@
           <a:noFill/>
         </p:spPr>
         <p:txBody>
-          <a:bodyPr wrap="square" lIns="0" rIns="0" tIns="0" bIns="0">
+          <a:bodyPr wrap="square">
             <a:spAutoFit/>
           </a:bodyPr>
           <a:lstStyle/>

</xml_diff>

<commit_message>
Two-period probit coefplot: 1997-2017 vs the deck's 2018-2024 window
Co-Authored-By: Claude Fable 5 <noreply@anthropic.com>
Claude-Session: https://claude.ai/code/session_01DNzQPDcr3zfLTraMHUHqUn
</commit_message>
<xml_diff>
--- a/report/data_cluster/robustness_slides.pptx
+++ b/report/data_cluster/robustness_slides.pptx
@@ -3100,7 +3100,7 @@
         <p:spPr>
           <a:xfrm>
             <a:off x="502920" y="219456"/>
-            <a:ext cx="9326880" cy="566928"/>
+            <a:ext cx="10058400" cy="566928"/>
           </a:xfrm>
           <a:prstGeom prst="rect">
             <a:avLst/>
@@ -3120,14 +3120,14 @@
                 </a:solidFill>
                 <a:latin typeface="Garamond"/>
               </a:rPr>
-              <a:t>What correlates with leaving, 1997–2024</a:t>
+              <a:t>Are the margins stable over time?</a:t>
             </a:r>
           </a:p>
         </p:txBody>
       </p:sp>
       <p:pic>
         <p:nvPicPr>
-          <p:cNvPr id="3" name="Picture 2" descr="ame_allyears.png"/>
+          <p:cNvPr id="3" name="Picture 2" descr="ame_twoperiods.png"/>
           <p:cNvPicPr>
             <a:picLocks noChangeAspect="1"/>
           </p:cNvPicPr>
@@ -3141,8 +3141,8 @@
         </p:blipFill>
         <p:spPr>
           <a:xfrm>
-            <a:off x="1781694" y="960119"/>
-            <a:ext cx="8598130" cy="4892039"/>
+            <a:off x="1830144" y="914400"/>
+            <a:ext cx="8501230" cy="4983480"/>
           </a:xfrm>
           <a:prstGeom prst="rect">
             <a:avLst/>
@@ -3157,8 +3157,8 @@
         </p:nvSpPr>
         <p:spPr>
           <a:xfrm>
-            <a:off x="822960" y="6108192"/>
-            <a:ext cx="9326880" cy="548640"/>
+            <a:off x="822960" y="6053328"/>
+            <a:ext cx="9326880" cy="640080"/>
           </a:xfrm>
           <a:prstGeom prst="rect">
             <a:avLst/>
@@ -3178,7 +3178,7 @@
                 </a:solidFill>
                 <a:latin typeface="Garamond"/>
               </a:rPr>
-              <a:t>Probit average marginal effects in percentage points; N = 84,146 teacher-year observations, calendar 1997–2024. Benchmark: the sample's average annual leaving probability is 7.7%, so +4.5 points for a new baby raises the risk by over half its baseline. Health, disability and income controls exist only from the 2019 supplement; adding them (N = 18,571) leaves every margin unchanged.</a:t>
+              <a:t>Probit average marginal effects in percentage points, estimated separately on 1997–2017 and on the deck's window 2018–2024, with the controls available in every year. Benchmarks: average annual leaving probability 7.9% (1997–2017) and 7.3% (2018–2024). With the full controls (health, disability, income; available from 2019) the 2018–24 margins are unchanged.</a:t>
             </a:r>
           </a:p>
         </p:txBody>
@@ -3372,7 +3372,7 @@
         <p:spPr>
           <a:xfrm>
             <a:off x="502920" y="219456"/>
-            <a:ext cx="9326880" cy="566928"/>
+            <a:ext cx="10058400" cy="566928"/>
           </a:xfrm>
           <a:prstGeom prst="rect">
             <a:avLst/>
@@ -3512,7 +3512,7 @@
         <p:spPr>
           <a:xfrm>
             <a:off x="502920" y="219456"/>
-            <a:ext cx="9326880" cy="566928"/>
+            <a:ext cx="10058400" cy="566928"/>
           </a:xfrm>
           <a:prstGeom prst="rect">
             <a:avLst/>
@@ -3652,7 +3652,7 @@
         <p:spPr>
           <a:xfrm>
             <a:off x="502920" y="219456"/>
-            <a:ext cx="9326880" cy="566928"/>
+            <a:ext cx="10058400" cy="566928"/>
           </a:xfrm>
           <a:prstGeom prst="rect">
             <a:avLst/>

</xml_diff>